<commit_message>
chore(release): bump to 0.6.4, CHANGELOG, README release notes, deck
Single version-of-truth bump in CMakeLists.txt's project() call (src/version.h is
generated from it). Renames CHANGELOG.md's Unreleased section to 0.6.4 with every
entry kept. Adds the owner-approved 0.6.4 README release blurb above 0.6.3 (text
verbatim from replies/readme-064-blurb.draft.md) and updates the one-line "Latest:"
pointer to match; historical blurbs, including 0.6.2's 647-gate mention, are left
byte-for-byte unchanged. Rebuilds present/ripwire-showcase.pptx and .pdf from
deck5_ripwire_build.js (npm ci in a scratch copy, then LibreOffice 26.8) so the
deck's gate-count figure reads 649, matching the generator and the live binary,
instead of the stale 648 train 20 shipped with; no other deck content changed.

Co-Authored-By: Claude Sonnet 5 <noreply@anthropic.com>
</commit_message>
<xml_diff>
--- a/present/ripwire-showcase.pptx
+++ b/present/ripwire-showcase.pptx
@@ -24405,7 +24405,7 @@
                 <a:ea typeface="Arial" pitchFamily="34" charset="-122"/>
                 <a:cs typeface="Arial" pitchFamily="34" charset="-120"/>
               </a:rPr>
-              <a:t>648 gate scripts</a:t>
+              <a:t>649 gate scripts</a:t>
             </a:r>
             <a:endParaRPr lang="en-US" sz="1450" dirty="0"/>
           </a:p>
@@ -25145,7 +25145,7 @@
                 <a:ea typeface="Arial" pitchFamily="34" charset="-122"/>
                 <a:cs typeface="Arial" pitchFamily="34" charset="-120"/>
               </a:rPr>
-              <a:t>648</a:t>
+              <a:t>649</a:t>
             </a:r>
             <a:endParaRPr lang="en-US" sz="4200" dirty="0"/>
           </a:p>
@@ -32870,7 +32870,7 @@
                 <a:ea typeface="Arial" pitchFamily="34" charset="-122"/>
                 <a:cs typeface="Arial" pitchFamily="34" charset="-120"/>
               </a:rPr>
-              <a:t>648 gate scripts</a:t>
+              <a:t>649 gate scripts</a:t>
             </a:r>
             <a:endParaRPr lang="en-US" sz="1200" dirty="0"/>
           </a:p>

</xml_diff>